<commit_message>
fix(diseño-patrones): coherencia del caso, pesos de la Guía y rótulos del PDF
Co-Authored-By: Claude Opus 5.5 <noreply@anthropic.com>
</commit_message>
<xml_diff>
--- a/2026-B/disenio-patrones-arquitectonicos/unidad-01/slides/unidad-01-fundamentos.pptx
+++ b/2026-B/disenio-patrones-arquitectonicos/unidad-01/slides/unidad-01-fundamentos.pptx
@@ -9041,7 +9041,7 @@
                           </a:solidFill>
                           <a:latin typeface="Aptos"/>
                         </a:rPr>
-                        <a:t>Piden al mismo tiempo el viernes en la tarde</a:t>
+                        <a:t>Piden al mismo tiempo el jueves antes del cierre</a:t>
                       </a:r>
                     </a:p>
                   </a:txBody>
@@ -9133,7 +9133,7 @@
                           </a:solidFill>
                           <a:latin typeface="Aptos"/>
                         </a:rPr>
-                        <a:t>Operación normal, día de mercado</a:t>
+                        <a:t>Operación normal, día de cierre de pedidos</a:t>
                       </a:r>
                     </a:p>
                   </a:txBody>

</xml_diff>

<commit_message>
refactor(diseño-patrones): proyecto de aula (FO-IV-159) en lugar de ABP
- Guía del proyecto de aula en proyecto-aula/ (FO-IV-159 campo por campo),
  con el formato oficial y la plantilla del documento técnico (Anexo 2).
- abp/ queda como redirección por si el aula se restauró con enlaces viejos.
- Unidad 1 (OVA, práctica, manual, presentación) y hub actualizados.

Co-Authored-By: Claude Opus 5.5 <noreply@anthropic.com>
</commit_message>
<xml_diff>
--- a/2026-B/disenio-patrones-arquitectonicos/unidad-01/slides/unidad-01-fundamentos.pptx
+++ b/2026-B/disenio-patrones-arquitectonicos/unidad-01/slides/unidad-01-fundamentos.pptx
@@ -1331,7 +1331,7 @@
           <a:lstStyle/>
           <a:p>
             <a:r>
-              <a:t>EN VIVO. Leerlo como capacidades. Aclarar qué es este documento: material de apoyo de la unidad completa, no el guion de la hora. Recorrido en vivo de hoy (50 min): apertura, sección 1, el escenario de calidad (2), la clasificación (4), el caso Mercado Campesino (6) y el lanzamiento del proyecto ABP (7). El resto queda para estudiar con la OVA. Objetivo adicional de la OVA: analizar beneficios y desafíos de un patrón (sección 5 de este deck).</a:t>
+              <a:t>EN VIVO. Leerlo como capacidades. Aclarar qué es este documento: material de apoyo de la unidad completa, no el guion de la hora. Recorrido en vivo de hoy (50 min): apertura, sección 1, el escenario de calidad (2), la clasificación (4), el caso Mercado Campesino (6) y el lanzamiento del proyecto de aula (7). El resto queda para estudiar con la OVA. Objetivo adicional de la OVA: analizar beneficios y desafíos de un patrón (sección 5 de este deck).</a:t>
             </a:r>
           </a:p>
         </p:txBody>
@@ -1611,7 +1611,7 @@
           <a:lstStyle/>
           <a:p>
             <a:r>
-              <a:t>EN VIVO. Puente directo al proyecto ABP: la v1 (A2) es clásica, la v2 (A3) moderna, y la comparación entre ambas es la evidencia de la A3.</a:t>
+              <a:t>EN VIVO. Puente directo al proyecto de aula: la v1 (A2) es clásica, la v2 (A3) moderna, y la comparación entre ambas es la evidencia de la A3.</a:t>
             </a:r>
           </a:p>
         </p:txBody>
@@ -2591,7 +2591,7 @@
           <a:lstStyle/>
           <a:p>
             <a:r>
-              <a:t>EN VIVO (min 35-45). Las cuatro evaluaciones trabajan sobre el mismo sistema, el del reto que elige el equipo. A1 (20 %) es el diagnóstico, individual. A2 (20 %) la v1 con un patrón clásico, en equipo. El foro de la Unidad 3 (20 %) la decisión de migración, individual. A3 (40 %) la v2 moderna, el documento ABP y la sustentación del 3 de noviembre, en equipo. Antes de todo, el H0: equipo y reto el 13 de octubre.</a:t>
+              <a:t>EN VIVO (min 35-45). Las cuatro evaluaciones trabajan sobre el mismo sistema, el del reto que elige el equipo. A1 (20 %) es el diagnóstico, individual. A2 (20 %) la v1 con un patrón clásico, en equipo. El foro de la Unidad 3 (20 %) la decisión de migración, individual. A3 (40 %) la v2 moderna, el informe del proyecto de aula (FO-IV-159) con sus anexos y la sustentación del 3 de noviembre, en equipo. Antes de todo, el H0: equipo y reto el 13 de octubre.</a:t>
             </a:r>
           </a:p>
         </p:txBody>
@@ -2661,7 +2661,7 @@
           <a:lstStyle/>
           <a:p>
             <a:r>
-              <a:t>EN VIVO. Este es el porqué del ABP. Criterios medibles sugeridos en la Guía: costo de un cambio (archivos y líneas tocadas para la misma funcionalidad), acoplamiento, despliegue independiente, rendimiento, tolerancia a fallos y facilidad de prueba. Comando: git tag v1 y git push --tags.</a:t>
+              <a:t>EN VIVO. Este es el porqué del proyecto de aula. Criterios medibles sugeridos en la Guía: costo de un cambio (archivos y líneas tocadas para la misma funcionalidad), acoplamiento, despliegue independiente, rendimiento, tolerancia a fallos y facilidad de prueba. Comando: git tag v1 y git push --tags.</a:t>
             </a:r>
           </a:p>
         </p:txBody>
@@ -2731,7 +2731,7 @@
           <a:lstStyle/>
           <a:p>
             <a:r>
-              <a:t>EN VIVO. Detalle completo (actores, requisitos mínimos, atributos de calidad) en la Guía del proyecto ABP, enlazada en el Inicio del aula. Mercado Campesino no se puede elegir: es el ejemplo de los manuales. Si dos equipos eligen el mismo reto, cada uno delimita un alcance distinto. Se puede proponer un reto propio con aprobación del tutor en el H0.</a:t>
+              <a:t>EN VIVO. Detalle completo (actores, requisitos mínimos, atributos de calidad) en la Guía del proyecto de aula, enlazada en el Inicio del aula. Mercado Campesino no se puede elegir: es el ejemplo de los manuales. Si dos equipos eligen el mismo reto, cada uno delimita un alcance distinto. Se puede proponer un reto propio con aprobación del tutor en el H0.</a:t>
             </a:r>
           </a:p>
         </p:txBody>
@@ -2801,7 +2801,7 @@
           <a:lstStyle/>
           <a:p>
             <a:r>
-              <a:t>EN VIVO. No es una nota nueva ni un entregable aparte: es el documento técnico que ya pide la Actividad 3, organizado como ABP. Secciones: portada, problema, diagnóstico (síntesis de las A1 del equipo), v1, decisión de migración, v2, comparación medida, conclusiones con la contribución de cada integrante y referencias. Se sustenta el martes 3 de noviembre (8 minutos por equipo) y se entrega el domingo 8.</a:t>
+              <a:t>EN VIVO. El cierre es el Informe de Proyectos de Aula, formato institucional FO-IV-159 (Gestión de Investigación e Innovación): título, resumen de máximo 800 caracteres, planteamiento del problema, pregunta de investigación, justificación, objetivos, metodología, resultados, productos y bibliografía, más la pestaña ESTUDIANTE. No es una nota nueva: se califica dentro de la Actividad 3. El documento técnico que ya pide la A3 (mínimo 2.000 palabras: diagnóstico, v1, decisión, v2, comparación medida y contribución por integrante) va como Anexo 2 · Productos, con el repositorio y la presentación. La pestaña ESTUDIANTE lleva números de identificación: el informe se sube solo al aula, nunca al repositorio. Se sustenta el martes 3 de noviembre (8 minutos por equipo) y se entrega el domingo 8.</a:t>
             </a:r>
           </a:p>
         </p:txBody>
@@ -3151,7 +3151,7 @@
           <a:lstStyle/>
           <a:p>
             <a:r>
-              <a:t>Respuesta correcta: Un diagnóstico arquitectónico individual del reto del equipo. La A1 es el Hito 1: cada integrante escribe su diagnóstico del reto. La v1 llega en la A2 y el documento ABP en la A3.</a:t>
+              <a:t>Respuesta correcta: Un diagnóstico arquitectónico individual del reto del equipo. La A1 es el Hito 1: cada integrante escribe su diagnóstico del reto. La v1 llega en la A2 y el informe FO-IV-159 en la A3.</a:t>
             </a:r>
           </a:p>
         </p:txBody>
@@ -3221,7 +3221,7 @@
           <a:lstStyle/>
           <a:p>
             <a:r>
-              <a:t>EN VIVO (min 45-50). Síntesis y próximos pasos: (1) equipo y reto para el martes 13; (2) la OVA de la Unidad 1 y la Guía ABP están enlazadas en el aula; (3) la A1 vence el domingo 18. Próximo encuentro: martes 13 de octubre, patrones clásicos a fondo.</a:t>
+              <a:t>EN VIVO (min 45-50). Síntesis y próximos pasos: (1) equipo y reto para el martes 13; (2) la OVA de la Unidad 1 y la Guía del proyecto de aula están enlazadas en el aula; (3) la A1 vence el domingo 18. Próximo encuentro: martes 13 de octubre, patrones clásicos a fondo.</a:t>
             </a:r>
           </a:p>
         </p:txBody>
@@ -32976,7 +32976,7 @@
                 </a:solidFill>
                 <a:latin typeface="Aptos Display"/>
               </a:rPr>
-              <a:t>7. El proyecto ABP del curso</a:t>
+              <a:t>7. El proyecto de aula del curso</a:t>
             </a:r>
           </a:p>
         </p:txBody>
@@ -34185,7 +34185,7 @@
                 </a:solidFill>
                 <a:latin typeface="Aptos"/>
               </a:rPr>
-              <a:t>La Guía ABP explica el encadenamiento</a:t>
+              <a:t>La Guía del proyecto de aula lo explica</a:t>
             </a:r>
           </a:p>
         </p:txBody>
@@ -35893,7 +35893,7 @@
                 </a:solidFill>
                 <a:latin typeface="Aptos Display"/>
               </a:rPr>
-              <a:t>El documento ABP es el de la A3</a:t>
+              <a:t>El FO-IV-159 cierra el proyecto</a:t>
             </a:r>
           </a:p>
         </p:txBody>
@@ -36040,7 +36040,7 @@
                 </a:solidFill>
                 <a:latin typeface="Aptos"/>
               </a:rPr>
-              <a:t>Uno por equipo</a:t>
+              <a:t>Un informe por equipo</a:t>
             </a:r>
           </a:p>
         </p:txBody>
@@ -36198,7 +36198,7 @@
                 </a:solidFill>
                 <a:latin typeface="Aptos"/>
               </a:rPr>
-              <a:t>Mínimo 2.000 palabras, normas APA</a:t>
+              <a:t>Anexo 2: documento técnico y repositorio</a:t>
             </a:r>
           </a:p>
         </p:txBody>
@@ -36277,7 +36277,7 @@
                 </a:solidFill>
                 <a:latin typeface="Aptos"/>
               </a:rPr>
-              <a:t>Nueve secciones, del diagnóstico a la comparación</a:t>
+              <a:t>Identificaciones solo en el aula</a:t>
             </a:r>
           </a:p>
         </p:txBody>
@@ -36356,7 +36356,7 @@
                 </a:solidFill>
                 <a:latin typeface="Aptos"/>
               </a:rPr>
-              <a:t>Plantilla lista en la Guía ABP</a:t>
+              <a:t>Formato y plantilla en la Guía</a:t>
             </a:r>
           </a:p>
         </p:txBody>
@@ -40495,7 +40495,7 @@
                 </a:solidFill>
                 <a:latin typeface="Aptos"/>
               </a:rPr>
-              <a:t>El documento ABP completo</a:t>
+              <a:t>El informe FO-IV-159 completo</a:t>
             </a:r>
           </a:p>
         </p:txBody>

</xml_diff>